<commit_message>
docs(walkthrough): fix cross-scene consistency found in the re-check
A second fact-check confirmed the 21 earlier corrections and found smaller
consistency issues, now fixed:

- closing the push credentials dialog opens the device page before the list
- line manager Fatma gets the Line Manager sidebar, not the admin one
- shift data agrees across scenes: the employee-level Evening assignment
  goes to Said, Salim is left out of the bulk change and moves to
  Operations, and Khalid's history lists the department Night shift
- the dashboard shows a closed past working day (Thu 08 Oct) with the
  product's past-day subtitle, a Today button, Fri/Sat dips in the trend
  and deltas that match the series; narration says "each day"
- Sur replaces Dubai (UAE branches are off on Sunday); recent activity and
  approvals are in the product's order and branch attribution

Co-Authored-By: Claude Opus 5.5 <noreply@anthropic.com>
Claude-Session: https://claude.ai/code/session_01NCwL7VENq4zAUBkz5EU72F
</commit_message>
<xml_diff>
--- a/docs/media/walkthrough/FlowZa-Time-Enterprise.pptx
+++ b/docs/media/walkthrough/FlowZa-Time-Enterprise.pptx
@@ -111,27 +111,27 @@
   <p:extLst>
     <p:ext uri="{521415D9-36F7-43E2-AB2F-B90AF26B5E84}">
       <p14:sectionLst xmlns:p14="http://schemas.microsoft.com/office/powerpoint/2010/main">
-        <p14:section name="Introduction" id="{844d7527-7687-42cb-71db-97e0480897aa}">
+        <p14:section name="Introduction" id="{761cd54b-f136-49a8-73df-4acfcbcb789e}">
           <p14:sldIdLst>
             <p14:sldId id="256"/>
           </p14:sldIdLst>
         </p14:section>
-        <p14:section name="Set up" id="{436b7713-3bf4-217b-c16b-6125beef6da3}">
+        <p14:section name="Set up" id="{d9deaeac-dc81-181c-6042-66892c01d065}">
           <p14:sldIdLst>
             <p14:sldId id="257"/>
           </p14:sldIdLst>
         </p14:section>
-        <p14:section name="Workforce changes" id="{d857fb57-9ee5-c3ce-b002-96151ca17e00}">
+        <p14:section name="Workforce changes" id="{61ff5eaa-8222-f7f4-7bb3-8d10b4c8fb5c}">
           <p14:sldIdLst>
             <p14:sldId id="258"/>
           </p14:sldIdLst>
         </p14:section>
-        <p14:section name="Leave &amp; approvals" id="{5e29377a-a374-033c-2584-66b66535cf94}">
+        <p14:section name="Leave &amp; approvals" id="{6bebdedf-50be-6080-3eee-084efa2a4c7a}">
           <p14:sldIdLst>
             <p14:sldId id="259"/>
           </p14:sldIdLst>
         </p14:section>
-        <p14:section name="Dashboard" id="{ee0501f5-413f-91c6-c932-0af1231b4724}">
+        <p14:section name="Dashboard" id="{f01a04e9-67f7-de0b-734d-50710b61c371}">
           <p14:sldIdLst>
             <p14:sldId id="260"/>
           </p14:sldIdLst>
@@ -892,7 +892,7 @@
           <a:p>
             <a:r>
               <a:rPr lang="en-US" dirty="0"/>
-              <a:t>Finally, configure and monitor. Settings cover regional options, attendance rules, sync, notifications and security, while roles decide who sees which branch. Pick one of seven dashboard styles and a layout: Overview, Operations or Executive. The dashboard shows who is present, absent, on leave or late today, then the attendance trend, attendance by branch, recent activity and the approvals waiting for you, with reports in PDF, Excel or CSV. See it for yourself at flowza.com.</a:t>
+              <a:t>Finally, configure and monitor. Settings cover regional options, attendance rules, sync, notifications and security, while roles decide who sees which branch. Pick one of seven dashboard styles and a layout: Overview, Operations or Executive. The dashboard shows each day at a glance: who was present, absent, on leave or late, then the attendance trend, attendance by branch, recent activity and the approvals waiting for you, with reports in PDF, Excel or CSV. See it for yourself at flowza.com.</a:t>
             </a:r>
             <a:endParaRPr lang="en-US" dirty="0"/>
           </a:p>
@@ -6406,7 +6406,7 @@
                   <a:srgbClr val="B9D3CA"/>
                 </a:solidFill>
               </a:rPr>
-              <a:t>Example dashboard: today at a glance</a:t>
+              <a:t>Example dashboard: one working day at a glance</a:t>
             </a:r>
             <a:endParaRPr lang="en-US" sz="1400" dirty="0"/>
           </a:p>

</xml_diff>

<commit_message>
docs(walkthrough): align the last details with the product
From the confirmation check of the re-check fixes:

- the line manager sidebar lists all eight My workspace pages
- the device page after registering shows the product's subtitle, badge
  row and Status / Identity cards
- the 08 Oct activity list uses existing employees and the blue check-out
  dot; the admin's waiting approvals are types routed to her (correction,
  leave at level 2, comp-off) and her sidebar badge matches
- the sick-leave example moves to Said, Maryam's leave shows as pending on
  the calendar, and the people scene's assignment example no longer moves
  Khalid to Night

Co-Authored-By: Claude Opus 5.5 <noreply@anthropic.com>
Claude-Session: https://claude.ai/code/session_01NCwL7VENq4zAUBkz5EU72F
</commit_message>
<xml_diff>
--- a/docs/media/walkthrough/FlowZa-Time-Enterprise.pptx
+++ b/docs/media/walkthrough/FlowZa-Time-Enterprise.pptx
@@ -111,27 +111,27 @@
   <p:extLst>
     <p:ext uri="{521415D9-36F7-43E2-AB2F-B90AF26B5E84}">
       <p14:sectionLst xmlns:p14="http://schemas.microsoft.com/office/powerpoint/2010/main">
-        <p14:section name="Introduction" id="{761cd54b-f136-49a8-73df-4acfcbcb789e}">
+        <p14:section name="Introduction" id="{ab32699f-66c7-d0b7-5772-bf003a34dd0f}">
           <p14:sldIdLst>
             <p14:sldId id="256"/>
           </p14:sldIdLst>
         </p14:section>
-        <p14:section name="Set up" id="{d9deaeac-dc81-181c-6042-66892c01d065}">
+        <p14:section name="Set up" id="{c533bde0-f79c-d161-0d20-fd7eb2bd2221}">
           <p14:sldIdLst>
             <p14:sldId id="257"/>
           </p14:sldIdLst>
         </p14:section>
-        <p14:section name="Workforce changes" id="{61ff5eaa-8222-f7f4-7bb3-8d10b4c8fb5c}">
+        <p14:section name="Workforce changes" id="{e89a576f-c1de-4c4d-e966-9582b0bf690b}">
           <p14:sldIdLst>
             <p14:sldId id="258"/>
           </p14:sldIdLst>
         </p14:section>
-        <p14:section name="Leave &amp; approvals" id="{6bebdedf-50be-6080-3eee-084efa2a4c7a}">
+        <p14:section name="Leave &amp; approvals" id="{a69c02d4-b0f3-fed1-2c77-70dcacfc18fc}">
           <p14:sldIdLst>
             <p14:sldId id="259"/>
           </p14:sldIdLst>
         </p14:section>
-        <p14:section name="Dashboard" id="{f01a04e9-67f7-de0b-734d-50710b61c371}">
+        <p14:section name="Dashboard" id="{e6354ed5-6872-9ae0-d30b-edbe2ee28494}">
           <p14:sldIdLst>
             <p14:sldId id="260"/>
           </p14:sldIdLst>

</xml_diff>